<commit_message>
QAOA N=3 en hardware real (ibm_kingston) y material final con los nombres del equipo
- results/hardware.json: un job en ibm_kingston (job dbefhdom94ac738rnc00, 4096 shots, 5 s de QPU)
  con los ángulos optimizados en el simulador. Mixer XY: 25.4% válidas (ideal 78.9%, azar 22.2%);
  mixer X: 6.3% (ideal 13.7%, azar 1.2%); ambos muestrean el óptimo 24
- dashboard, README, PPT, guion y descripción breve: simulador Qiskit Aer + una corrida en
  ibm_kingston, reportada aparte; un hardware fake nunca se publica
- scripts/hardware.py: salida UTF-8 en la consola de Windows
- portada con los 4 integrantes

Co-Authored-By: Claude Opus 5.5 <noreply@anthropic.com>
</commit_message>
<xml_diff>
--- a/entrega/QGate.pptx
+++ b/entrega/QGate.pptx
@@ -789,7 +789,7 @@
           <a:lstStyle/>
           <a:p>
             <a:r>
-              <a:t>Simular el problema completo exige 100 qubits: imposible. QGate usa siempre piezas de 9. Elegimos lambda con un criterio analítico y lo validamos con un barrido. Medimos el ruido: con 1% el mixer XY pierde casi toda su ventaja de factibilidad. Todo es simulador.</a:t>
+              <a:t>Simular el problema completo exige 100 qubits: imposible. QGate usa siempre piezas de 9. Elegimos lambda con un criterio analítico y lo validamos con un barrido. Medimos el ruido: con 1% el mixer XY pierde casi toda su ventaja de factibilidad. Además corrimos N=3 una vez en ibm_kingston de IBM Quantum: con mixer XY salieron 25% de asignaciones válidas, frente a 79% ideal y 22% al azar.</a:t>
             </a:r>
           </a:p>
         </p:txBody>
@@ -999,7 +999,7 @@
           <a:lstStyle/>
           <a:p>
             <a:r>
-              <a:t>Hoy lo cuántico aporta estructura y concentración de probabilidad en piezas pequeñas, no velocidad en simulador, y lo mostramos con números. El siguiente paso es hardware IBM real, piezas más grandes y mitigación de errores. Gracias.</a:t>
+              <a:t>Hoy lo cuántico aporta estructura y concentración de probabilidad en piezas pequeñas, no velocidad en simulador, y lo mostramos con números. Lo medimos en el simulador Qiskit Aer y en una corrida en ibm_kingston de IBM Quantum. El siguiente paso es más tiempo de hardware, piezas más grandes y mitigación de errores. Gracias.</a:t>
             </a:r>
           </a:p>
         </p:txBody>

</xml_diff>